<commit_message>
Add speaker notes to all 18 deck slides
Each slide's notes pane now carries a natural spoken script (~45-180 words) with a
timing cue, smooth transitions between slides, and anticipated-question hints on
the key slides (honesty ladder, AI generator). Total talk ~13-15 min. Notes are
generated in make_promotion_deck.py so they regenerate with the deck.

Co-Authored-By: Claude Opus 4.8 <noreply@anthropic.com>
Claude-Session: https://claude.ai/code/session_012wzrKXvU8WAtkCgKW6bWKY
</commit_message>
<xml_diff>
--- a/analysis/outputs/Papulacandin_promotion_report.pptx
+++ b/analysis/outputs/Papulacandin_promotion_report.pptx
@@ -122,6 +122,1616 @@
     </a:lvl9pPr>
   </p:defaultTextStyle>
 </p:presentation>
+</file>
+
+<file path=ppt/notesMasters/notesMaster1.xml><?xml version="1.0" encoding="utf-8"?>
+<p:notesMaster xmlns:a="http://schemas.openxmlformats.org/drawingml/2006/main" xmlns:p="http://schemas.openxmlformats.org/presentationml/2006/main" xmlns:r="http://schemas.openxmlformats.org/officeDocument/2006/relationships">
+  <p:cSld>
+    <p:bg>
+      <p:bgRef idx="1001">
+        <a:schemeClr val="bg1"/>
+      </p:bgRef>
+    </p:bg>
+    <p:spTree>
+      <p:nvGrpSpPr>
+        <p:cNvPr id="1" name=""/>
+        <p:cNvGrpSpPr/>
+        <p:nvPr/>
+      </p:nvGrpSpPr>
+      <p:grpSpPr>
+        <a:xfrm>
+          <a:off x="0" y="0"/>
+          <a:ext cx="0" cy="0"/>
+          <a:chOff x="0" y="0"/>
+          <a:chExt cx="0" cy="0"/>
+        </a:xfrm>
+      </p:grpSpPr>
+      <p:sp>
+        <p:nvSpPr>
+          <p:cNvPr id="2" name="Header Placeholder 1"/>
+          <p:cNvSpPr>
+            <a:spLocks noGrp="1"/>
+          </p:cNvSpPr>
+          <p:nvPr>
+            <p:ph type="hdr" sz="quarter"/>
+          </p:nvPr>
+        </p:nvSpPr>
+        <p:spPr>
+          <a:xfrm>
+            <a:off x="0" y="0"/>
+            <a:ext cx="2971800" cy="457200"/>
+          </a:xfrm>
+          <a:prstGeom prst="rect">
+            <a:avLst/>
+          </a:prstGeom>
+        </p:spPr>
+        <p:txBody>
+          <a:bodyPr vert="horz" lIns="91440" tIns="45720" rIns="91440" bIns="45720" rtlCol="0"/>
+          <a:lstStyle>
+            <a:lvl1pPr algn="l">
+              <a:defRPr sz="1200"/>
+            </a:lvl1pPr>
+          </a:lstStyle>
+          <a:p>
+            <a:endParaRPr lang="en-US"/>
+          </a:p>
+        </p:txBody>
+      </p:sp>
+      <p:sp>
+        <p:nvSpPr>
+          <p:cNvPr id="3" name="Date Placeholder 2"/>
+          <p:cNvSpPr>
+            <a:spLocks noGrp="1"/>
+          </p:cNvSpPr>
+          <p:nvPr>
+            <p:ph type="dt" idx="1"/>
+          </p:nvPr>
+        </p:nvSpPr>
+        <p:spPr>
+          <a:xfrm>
+            <a:off x="3884613" y="0"/>
+            <a:ext cx="2971800" cy="457200"/>
+          </a:xfrm>
+          <a:prstGeom prst="rect">
+            <a:avLst/>
+          </a:prstGeom>
+        </p:spPr>
+        <p:txBody>
+          <a:bodyPr vert="horz" lIns="91440" tIns="45720" rIns="91440" bIns="45720" rtlCol="0"/>
+          <a:lstStyle>
+            <a:lvl1pPr algn="r">
+              <a:defRPr sz="1200"/>
+            </a:lvl1pPr>
+          </a:lstStyle>
+          <a:p>
+            <a:fld id="{0F89C1C7-3DCD-1040-A9CF-14679D8B5DDD}" type="datetimeFigureOut">
+              <a:rPr lang="en-US" smtClean="0"/>
+              <a:t>10/17/16</a:t>
+            </a:fld>
+            <a:endParaRPr lang="en-US"/>
+          </a:p>
+        </p:txBody>
+      </p:sp>
+      <p:sp>
+        <p:nvSpPr>
+          <p:cNvPr id="4" name="Slide Image Placeholder 3"/>
+          <p:cNvSpPr>
+            <a:spLocks noGrp="1" noRot="1" noChangeAspect="1"/>
+          </p:cNvSpPr>
+          <p:nvPr>
+            <p:ph type="sldImg" idx="2"/>
+          </p:nvPr>
+        </p:nvSpPr>
+        <p:spPr>
+          <a:xfrm>
+            <a:off x="1143000" y="685800"/>
+            <a:ext cx="4572000" cy="3429000"/>
+          </a:xfrm>
+          <a:prstGeom prst="rect">
+            <a:avLst/>
+          </a:prstGeom>
+          <a:noFill/>
+          <a:ln w="12700">
+            <a:solidFill>
+              <a:prstClr val="black"/>
+            </a:solidFill>
+          </a:ln>
+        </p:spPr>
+        <p:txBody>
+          <a:bodyPr vert="horz" lIns="91440" tIns="45720" rIns="91440" bIns="45720" rtlCol="0" anchor="ctr"/>
+          <a:lstStyle/>
+          <a:p>
+            <a:endParaRPr lang="en-US"/>
+          </a:p>
+        </p:txBody>
+      </p:sp>
+      <p:sp>
+        <p:nvSpPr>
+          <p:cNvPr id="5" name="Notes Placeholder 4"/>
+          <p:cNvSpPr>
+            <a:spLocks noGrp="1"/>
+          </p:cNvSpPr>
+          <p:nvPr>
+            <p:ph type="body" sz="quarter" idx="3"/>
+          </p:nvPr>
+        </p:nvSpPr>
+        <p:spPr>
+          <a:xfrm>
+            <a:off x="685800" y="4343400"/>
+            <a:ext cx="5486400" cy="4114800"/>
+          </a:xfrm>
+          <a:prstGeom prst="rect">
+            <a:avLst/>
+          </a:prstGeom>
+        </p:spPr>
+        <p:txBody>
+          <a:bodyPr vert="horz" lIns="91440" tIns="45720" rIns="91440" bIns="45720" rtlCol="0"/>
+          <a:lstStyle/>
+          <a:p>
+            <a:pPr lvl="0"/>
+            <a:r>
+              <a:rPr lang="en-US" smtClean="0"/>
+              <a:t>Click to edit Master text styles</a:t>
+            </a:r>
+          </a:p>
+          <a:p>
+            <a:pPr lvl="1"/>
+            <a:r>
+              <a:rPr lang="en-US" smtClean="0"/>
+              <a:t>Second level</a:t>
+            </a:r>
+          </a:p>
+          <a:p>
+            <a:pPr lvl="2"/>
+            <a:r>
+              <a:rPr lang="en-US" smtClean="0"/>
+              <a:t>Third level</a:t>
+            </a:r>
+          </a:p>
+          <a:p>
+            <a:pPr lvl="3"/>
+            <a:r>
+              <a:rPr lang="en-US" smtClean="0"/>
+              <a:t>Fourth level</a:t>
+            </a:r>
+          </a:p>
+          <a:p>
+            <a:pPr lvl="4"/>
+            <a:r>
+              <a:rPr lang="en-US" smtClean="0"/>
+              <a:t>Fifth level</a:t>
+            </a:r>
+            <a:endParaRPr lang="en-US"/>
+          </a:p>
+        </p:txBody>
+      </p:sp>
+      <p:sp>
+        <p:nvSpPr>
+          <p:cNvPr id="6" name="Footer Placeholder 5"/>
+          <p:cNvSpPr>
+            <a:spLocks noGrp="1"/>
+          </p:cNvSpPr>
+          <p:nvPr>
+            <p:ph type="ftr" sz="quarter" idx="4"/>
+          </p:nvPr>
+        </p:nvSpPr>
+        <p:spPr>
+          <a:xfrm>
+            <a:off x="0" y="8685213"/>
+            <a:ext cx="2971800" cy="457200"/>
+          </a:xfrm>
+          <a:prstGeom prst="rect">
+            <a:avLst/>
+          </a:prstGeom>
+        </p:spPr>
+        <p:txBody>
+          <a:bodyPr vert="horz" lIns="91440" tIns="45720" rIns="91440" bIns="45720" rtlCol="0" anchor="b"/>
+          <a:lstStyle>
+            <a:lvl1pPr algn="l">
+              <a:defRPr sz="1200"/>
+            </a:lvl1pPr>
+          </a:lstStyle>
+          <a:p>
+            <a:endParaRPr lang="en-US"/>
+          </a:p>
+        </p:txBody>
+      </p:sp>
+      <p:sp>
+        <p:nvSpPr>
+          <p:cNvPr id="7" name="Slide Number Placeholder 6"/>
+          <p:cNvSpPr>
+            <a:spLocks noGrp="1"/>
+          </p:cNvSpPr>
+          <p:nvPr>
+            <p:ph type="sldNum" sz="quarter" idx="5"/>
+          </p:nvPr>
+        </p:nvSpPr>
+        <p:spPr>
+          <a:xfrm>
+            <a:off x="3884613" y="8685213"/>
+            <a:ext cx="2971800" cy="457200"/>
+          </a:xfrm>
+          <a:prstGeom prst="rect">
+            <a:avLst/>
+          </a:prstGeom>
+        </p:spPr>
+        <p:txBody>
+          <a:bodyPr vert="horz" lIns="91440" tIns="45720" rIns="91440" bIns="45720" rtlCol="0" anchor="b"/>
+          <a:lstStyle>
+            <a:lvl1pPr algn="r">
+              <a:defRPr sz="1200"/>
+            </a:lvl1pPr>
+          </a:lstStyle>
+          <a:p>
+            <a:fld id="{BB5E49A5-4136-284D-997B-48E1D791AD67}" type="slidenum">
+              <a:rPr lang="en-US" smtClean="0"/>
+              <a:t>‹#›</a:t>
+            </a:fld>
+            <a:endParaRPr lang="en-US"/>
+          </a:p>
+        </p:txBody>
+      </p:sp>
+    </p:spTree>
+    <p:extLst>
+      <p:ext uri="{BB962C8B-B14F-4D97-AF65-F5344CB8AC3E}">
+        <p14:creationId xmlns:p14="http://schemas.microsoft.com/office/powerpoint/2010/main" val="2623252185"/>
+      </p:ext>
+    </p:extLst>
+  </p:cSld>
+  <p:clrMap bg1="lt1" tx1="dk1" bg2="lt2" tx2="dk2" accent1="accent1" accent2="accent2" accent3="accent3" accent4="accent4" accent5="accent5" accent6="accent6" hlink="hlink" folHlink="folHlink"/>
+  <p:notesStyle>
+    <a:lvl1pPr marL="0" algn="l" defTabSz="457200" rtl="0" eaLnBrk="1" latinLnBrk="0" hangingPunct="1">
+      <a:defRPr sz="1200" kern="1200">
+        <a:solidFill>
+          <a:schemeClr val="tx1"/>
+        </a:solidFill>
+        <a:latin typeface="+mn-lt"/>
+        <a:ea typeface="+mn-ea"/>
+        <a:cs typeface="+mn-cs"/>
+      </a:defRPr>
+    </a:lvl1pPr>
+    <a:lvl2pPr marL="457200" algn="l" defTabSz="457200" rtl="0" eaLnBrk="1" latinLnBrk="0" hangingPunct="1">
+      <a:defRPr sz="1200" kern="1200">
+        <a:solidFill>
+          <a:schemeClr val="tx1"/>
+        </a:solidFill>
+        <a:latin typeface="+mn-lt"/>
+        <a:ea typeface="+mn-ea"/>
+        <a:cs typeface="+mn-cs"/>
+      </a:defRPr>
+    </a:lvl2pPr>
+    <a:lvl3pPr marL="914400" algn="l" defTabSz="457200" rtl="0" eaLnBrk="1" latinLnBrk="0" hangingPunct="1">
+      <a:defRPr sz="1200" kern="1200">
+        <a:solidFill>
+          <a:schemeClr val="tx1"/>
+        </a:solidFill>
+        <a:latin typeface="+mn-lt"/>
+        <a:ea typeface="+mn-ea"/>
+        <a:cs typeface="+mn-cs"/>
+      </a:defRPr>
+    </a:lvl3pPr>
+    <a:lvl4pPr marL="1371600" algn="l" defTabSz="457200" rtl="0" eaLnBrk="1" latinLnBrk="0" hangingPunct="1">
+      <a:defRPr sz="1200" kern="1200">
+        <a:solidFill>
+          <a:schemeClr val="tx1"/>
+        </a:solidFill>
+        <a:latin typeface="+mn-lt"/>
+        <a:ea typeface="+mn-ea"/>
+        <a:cs typeface="+mn-cs"/>
+      </a:defRPr>
+    </a:lvl4pPr>
+    <a:lvl5pPr marL="1828800" algn="l" defTabSz="457200" rtl="0" eaLnBrk="1" latinLnBrk="0" hangingPunct="1">
+      <a:defRPr sz="1200" kern="1200">
+        <a:solidFill>
+          <a:schemeClr val="tx1"/>
+        </a:solidFill>
+        <a:latin typeface="+mn-lt"/>
+        <a:ea typeface="+mn-ea"/>
+        <a:cs typeface="+mn-cs"/>
+      </a:defRPr>
+    </a:lvl5pPr>
+    <a:lvl6pPr marL="2286000" algn="l" defTabSz="457200" rtl="0" eaLnBrk="1" latinLnBrk="0" hangingPunct="1">
+      <a:defRPr sz="1200" kern="1200">
+        <a:solidFill>
+          <a:schemeClr val="tx1"/>
+        </a:solidFill>
+        <a:latin typeface="+mn-lt"/>
+        <a:ea typeface="+mn-ea"/>
+        <a:cs typeface="+mn-cs"/>
+      </a:defRPr>
+    </a:lvl6pPr>
+    <a:lvl7pPr marL="2743200" algn="l" defTabSz="457200" rtl="0" eaLnBrk="1" latinLnBrk="0" hangingPunct="1">
+      <a:defRPr sz="1200" kern="1200">
+        <a:solidFill>
+          <a:schemeClr val="tx1"/>
+        </a:solidFill>
+        <a:latin typeface="+mn-lt"/>
+        <a:ea typeface="+mn-ea"/>
+        <a:cs typeface="+mn-cs"/>
+      </a:defRPr>
+    </a:lvl7pPr>
+    <a:lvl8pPr marL="3200400" algn="l" defTabSz="457200" rtl="0" eaLnBrk="1" latinLnBrk="0" hangingPunct="1">
+      <a:defRPr sz="1200" kern="1200">
+        <a:solidFill>
+          <a:schemeClr val="tx1"/>
+        </a:solidFill>
+        <a:latin typeface="+mn-lt"/>
+        <a:ea typeface="+mn-ea"/>
+        <a:cs typeface="+mn-cs"/>
+      </a:defRPr>
+    </a:lvl8pPr>
+    <a:lvl9pPr marL="3657600" algn="l" defTabSz="457200" rtl="0" eaLnBrk="1" latinLnBrk="0" hangingPunct="1">
+      <a:defRPr sz="1200" kern="1200">
+        <a:solidFill>
+          <a:schemeClr val="tx1"/>
+        </a:solidFill>
+        <a:latin typeface="+mn-lt"/>
+        <a:ea typeface="+mn-ea"/>
+        <a:cs typeface="+mn-cs"/>
+      </a:defRPr>
+    </a:lvl9pPr>
+  </p:notesStyle>
+</p:notesMaster>
+</file>
+
+<file path=ppt/notesSlides/notesSlide1.xml><?xml version="1.0" encoding="utf-8"?>
+<p:notes xmlns:a="http://schemas.openxmlformats.org/drawingml/2006/main" xmlns:p="http://schemas.openxmlformats.org/presentationml/2006/main" xmlns:r="http://schemas.openxmlformats.org/officeDocument/2006/relationships">
+  <p:cSld>
+    <p:spTree>
+      <p:nvGrpSpPr>
+        <p:cNvPr id="1" name=""/>
+        <p:cNvGrpSpPr/>
+        <p:nvPr/>
+      </p:nvGrpSpPr>
+      <p:grpSpPr>
+        <a:xfrm>
+          <a:off x="0" y="0"/>
+          <a:ext cx="0" cy="0"/>
+          <a:chOff x="0" y="0"/>
+          <a:chExt cx="0" cy="0"/>
+        </a:xfrm>
+      </p:grpSpPr>
+      <p:sp>
+        <p:nvSpPr>
+          <p:cNvPr id="2" name="Slide Image Placeholder 1"/>
+          <p:cNvSpPr>
+            <a:spLocks noGrp="1"/>
+          </p:cNvSpPr>
+          <p:nvPr>
+            <p:ph type="sldImg" idx="2"/>
+          </p:nvPr>
+        </p:nvSpPr>
+        <p:spPr/>
+      </p:sp>
+      <p:sp>
+        <p:nvSpPr>
+          <p:cNvPr id="3" name="Notes Placeholder 2"/>
+          <p:cNvSpPr>
+            <a:spLocks noGrp="1"/>
+          </p:cNvSpPr>
+          <p:nvPr>
+            <p:ph type="body" idx="3" sz="quarter"/>
+          </p:nvPr>
+        </p:nvSpPr>
+        <p:spPr/>
+        <p:txBody>
+          <a:bodyPr/>
+          <a:lstStyle/>
+          <a:p>
+            <a:r>
+              <a:t>[~30s] Good morning, and thank you for being here. Over the next fifteen minutes I'll walk you through a drug-discovery program that combines artificial intelligence with quantum chemistry to attack a stubborn problem in antifungal medicine. I'll keep the chemistry light and focus on the ideas and the reasoning. The one-sentence version is on the slide: we set out to design antifungal molecules that keep working in blood — and along the way we built a complete, reusable computational platform and learned exactly where AI can and cannot help. Let me start with why this matters.</a:t>
+            </a:r>
+          </a:p>
+        </p:txBody>
+      </p:sp>
+      <p:sp>
+        <p:nvSpPr>
+          <p:cNvPr id="4" name="Slide Number Placeholder 3"/>
+          <p:cNvSpPr>
+            <a:spLocks noGrp="1"/>
+          </p:cNvSpPr>
+          <p:nvPr>
+            <p:ph type="sldNum" idx="5" sz="quarter"/>
+          </p:nvPr>
+        </p:nvSpPr>
+        <p:spPr/>
+      </p:sp>
+    </p:spTree>
+  </p:cSld>
+  <p:clrMapOvr>
+    <a:masterClrMapping/>
+  </p:clrMapOvr>
+</p:notes>
+</file>
+
+<file path=ppt/notesSlides/notesSlide10.xml><?xml version="1.0" encoding="utf-8"?>
+<p:notes xmlns:a="http://schemas.openxmlformats.org/drawingml/2006/main" xmlns:p="http://schemas.openxmlformats.org/presentationml/2006/main" xmlns:r="http://schemas.openxmlformats.org/officeDocument/2006/relationships">
+  <p:cSld>
+    <p:spTree>
+      <p:nvGrpSpPr>
+        <p:cNvPr id="1" name=""/>
+        <p:cNvGrpSpPr/>
+        <p:nvPr/>
+      </p:nvGrpSpPr>
+      <p:grpSpPr>
+        <a:xfrm>
+          <a:off x="0" y="0"/>
+          <a:ext cx="0" cy="0"/>
+          <a:chOff x="0" y="0"/>
+          <a:chExt cx="0" cy="0"/>
+        </a:xfrm>
+      </p:grpSpPr>
+      <p:sp>
+        <p:nvSpPr>
+          <p:cNvPr id="2" name="Slide Image Placeholder 1"/>
+          <p:cNvSpPr>
+            <a:spLocks noGrp="1"/>
+          </p:cNvSpPr>
+          <p:nvPr>
+            <p:ph type="sldImg" idx="2"/>
+          </p:nvPr>
+        </p:nvSpPr>
+        <p:spPr/>
+      </p:sp>
+      <p:sp>
+        <p:nvSpPr>
+          <p:cNvPr id="3" name="Notes Placeholder 2"/>
+          <p:cNvSpPr>
+            <a:spLocks noGrp="1"/>
+          </p:cNvSpPr>
+          <p:nvPr>
+            <p:ph type="body" idx="3" sz="quarter"/>
+          </p:nvPr>
+        </p:nvSpPr>
+        <p:spPr/>
+        <p:txBody>
+          <a:bodyPr/>
+          <a:lstStyle/>
+          <a:p>
+            <a:r>
+              <a:t>[~65s] Here is where borrowing from approved drugs pays off. The echinocandins are antifungals already on the market that hit the same target and carry the same kind of greasy tail, so their well-documented serum behavior is a natural second opinion. Two lessons. First: the tail is required for the drug to work at all — it anchors the molecule into the membrane — so we cannot simply make it water-friendly or cut it off. Second, and more useful: among drugs that keep their potency, the one with the smallest serum problem, caspofungin, has a flexible, branched tail, while the worst offenders have rigid, flat, aromatic tails — good zone lower-left, bad zone upper-right. Our native molecule's tail is a rigid, flat chain, sitting squarely in the bad zone. That single observation redirected our whole design.</a:t>
+            </a:r>
+          </a:p>
+        </p:txBody>
+      </p:sp>
+      <p:sp>
+        <p:nvSpPr>
+          <p:cNvPr id="4" name="Slide Number Placeholder 3"/>
+          <p:cNvSpPr>
+            <a:spLocks noGrp="1"/>
+          </p:cNvSpPr>
+          <p:nvPr>
+            <p:ph type="sldNum" idx="5" sz="quarter"/>
+          </p:nvPr>
+        </p:nvSpPr>
+        <p:spPr/>
+      </p:sp>
+    </p:spTree>
+  </p:cSld>
+  <p:clrMapOvr>
+    <a:masterClrMapping/>
+  </p:clrMapOvr>
+</p:notes>
+</file>
+
+<file path=ppt/notesSlides/notesSlide11.xml><?xml version="1.0" encoding="utf-8"?>
+<p:notes xmlns:a="http://schemas.openxmlformats.org/drawingml/2006/main" xmlns:p="http://schemas.openxmlformats.org/presentationml/2006/main" xmlns:r="http://schemas.openxmlformats.org/officeDocument/2006/relationships">
+  <p:cSld>
+    <p:spTree>
+      <p:nvGrpSpPr>
+        <p:cNvPr id="1" name=""/>
+        <p:cNvGrpSpPr/>
+        <p:nvPr/>
+      </p:nvGrpSpPr>
+      <p:grpSpPr>
+        <a:xfrm>
+          <a:off x="0" y="0"/>
+          <a:ext cx="0" cy="0"/>
+          <a:chOff x="0" y="0"/>
+          <a:chExt cx="0" cy="0"/>
+        </a:xfrm>
+      </p:grpSpPr>
+      <p:sp>
+        <p:nvSpPr>
+          <p:cNvPr id="2" name="Slide Image Placeholder 1"/>
+          <p:cNvSpPr>
+            <a:spLocks noGrp="1"/>
+          </p:cNvSpPr>
+          <p:nvPr>
+            <p:ph type="sldImg" idx="2"/>
+          </p:nvPr>
+        </p:nvSpPr>
+        <p:spPr/>
+      </p:sp>
+      <p:sp>
+        <p:nvSpPr>
+          <p:cNvPr id="3" name="Notes Placeholder 2"/>
+          <p:cNvSpPr>
+            <a:spLocks noGrp="1"/>
+          </p:cNvSpPr>
+          <p:nvPr>
+            <p:ph type="body" idx="3" sz="quarter"/>
+          </p:nvPr>
+        </p:nvSpPr>
+        <p:spPr/>
+        <p:txBody>
+          <a:bodyPr/>
+          <a:lstStyle/>
+          <a:p>
+            <a:r>
+              <a:t>[~55s] Now the AI. We built a generator that invents new molecules on our scaffold. But — discipline again — we did not let it optimize a made-up target. We first checked its scoring rule against real measured data; that is the plot on the left, showing the reward genuinely tracks serum tolerance across our known compounds, honestly reported as a weak-but-real trend. And we designed it to produce a spread of molecules that would test our idea, not just confirm it. So the AI here is not a black box making bold claims — it is a disciplined design tool whose scoring we validated before trusting. [If asked 'why not a bigger neural network?': with no measured labels yet, a bigger model just learns our unvalidated guess faster — garbage in. That is why the next step is the lab.]</a:t>
+            </a:r>
+          </a:p>
+        </p:txBody>
+      </p:sp>
+      <p:sp>
+        <p:nvSpPr>
+          <p:cNvPr id="4" name="Slide Number Placeholder 3"/>
+          <p:cNvSpPr>
+            <a:spLocks noGrp="1"/>
+          </p:cNvSpPr>
+          <p:nvPr>
+            <p:ph type="sldNum" idx="5" sz="quarter"/>
+          </p:nvPr>
+        </p:nvSpPr>
+        <p:spPr/>
+      </p:sp>
+    </p:spTree>
+  </p:cSld>
+  <p:clrMapOvr>
+    <a:masterClrMapping/>
+  </p:clrMapOvr>
+</p:notes>
+</file>
+
+<file path=ppt/notesSlides/notesSlide12.xml><?xml version="1.0" encoding="utf-8"?>
+<p:notes xmlns:a="http://schemas.openxmlformats.org/drawingml/2006/main" xmlns:p="http://schemas.openxmlformats.org/presentationml/2006/main" xmlns:r="http://schemas.openxmlformats.org/officeDocument/2006/relationships">
+  <p:cSld>
+    <p:spTree>
+      <p:nvGrpSpPr>
+        <p:cNvPr id="1" name=""/>
+        <p:cNvGrpSpPr/>
+        <p:nvPr/>
+      </p:nvGrpSpPr>
+      <p:grpSpPr>
+        <a:xfrm>
+          <a:off x="0" y="0"/>
+          <a:ext cx="0" cy="0"/>
+          <a:chOff x="0" y="0"/>
+          <a:chExt cx="0" cy="0"/>
+        </a:xfrm>
+      </p:grpSpPr>
+      <p:sp>
+        <p:nvSpPr>
+          <p:cNvPr id="2" name="Slide Image Placeholder 1"/>
+          <p:cNvSpPr>
+            <a:spLocks noGrp="1"/>
+          </p:cNvSpPr>
+          <p:nvPr>
+            <p:ph type="sldImg" idx="2"/>
+          </p:nvPr>
+        </p:nvSpPr>
+        <p:spPr/>
+      </p:sp>
+      <p:sp>
+        <p:nvSpPr>
+          <p:cNvPr id="3" name="Notes Placeholder 2"/>
+          <p:cNvSpPr>
+            <a:spLocks noGrp="1"/>
+          </p:cNvSpPr>
+          <p:nvPr>
+            <p:ph type="body" idx="3" sz="quarter"/>
+          </p:nvPr>
+        </p:nvSpPr>
+        <p:spPr/>
+        <p:txBody>
+          <a:bodyPr/>
+          <a:lstStyle/>
+          <a:p>
+            <a:r>
+              <a:t>[~45s] Round one: we asked the AI to redesign just the greasy tail, keeping the rest of the molecule fixed — a clean, one-variable experiment. This shows all twelve designed tails ranked by how much greasy surface they expose, lower being better, against the native baseline in red. At this cheaper tier only two beat the native tail — the two green bars. Encouraging. But we had learned not to trust the cheap tier, so we did the accurate re-check — the next slide.</a:t>
+            </a:r>
+          </a:p>
+        </p:txBody>
+      </p:sp>
+      <p:sp>
+        <p:nvSpPr>
+          <p:cNvPr id="4" name="Slide Number Placeholder 3"/>
+          <p:cNvSpPr>
+            <a:spLocks noGrp="1"/>
+          </p:cNvSpPr>
+          <p:nvPr>
+            <p:ph type="sldNum" idx="5" sz="quarter"/>
+          </p:nvPr>
+        </p:nvSpPr>
+        <p:spPr/>
+      </p:sp>
+    </p:spTree>
+  </p:cSld>
+  <p:clrMapOvr>
+    <a:masterClrMapping/>
+  </p:clrMapOvr>
+</p:notes>
+</file>
+
+<file path=ppt/notesSlides/notesSlide13.xml><?xml version="1.0" encoding="utf-8"?>
+<p:notes xmlns:a="http://schemas.openxmlformats.org/drawingml/2006/main" xmlns:p="http://schemas.openxmlformats.org/presentationml/2006/main" xmlns:r="http://schemas.openxmlformats.org/officeDocument/2006/relationships">
+  <p:cSld>
+    <p:spTree>
+      <p:nvGrpSpPr>
+        <p:cNvPr id="1" name=""/>
+        <p:cNvGrpSpPr/>
+        <p:nvPr/>
+      </p:nvGrpSpPr>
+      <p:grpSpPr>
+        <a:xfrm>
+          <a:off x="0" y="0"/>
+          <a:ext cx="0" cy="0"/>
+          <a:chOff x="0" y="0"/>
+          <a:chExt cx="0" cy="0"/>
+        </a:xfrm>
+      </p:grpSpPr>
+      <p:sp>
+        <p:nvSpPr>
+          <p:cNvPr id="2" name="Slide Image Placeholder 1"/>
+          <p:cNvSpPr>
+            <a:spLocks noGrp="1"/>
+          </p:cNvSpPr>
+          <p:nvPr>
+            <p:ph type="sldImg" idx="2"/>
+          </p:nvPr>
+        </p:nvSpPr>
+        <p:spPr/>
+      </p:sp>
+      <p:sp>
+        <p:nvSpPr>
+          <p:cNvPr id="3" name="Notes Placeholder 2"/>
+          <p:cNvSpPr>
+            <a:spLocks noGrp="1"/>
+          </p:cNvSpPr>
+          <p:nvPr>
+            <p:ph type="body" idx="3" sz="quarter"/>
+          </p:nvPr>
+        </p:nvSpPr>
+        <p:spPr/>
+        <p:txBody>
+          <a:bodyPr/>
+          <a:lstStyle/>
+          <a:p>
+            <a:r>
+              <a:t>[~55s] And here is the payoff of the funnel discipline. On the left, twelve designs down to two, and then, at the most accurate quantum level, zero survivors. On the right is why. Our top candidate looked better than native with the cheaper method — but the accurate method showed its water-friendly group folds back and hides inside the molecule, leaving it actually worse than where we started. A computational artifact. The important part: we caught it before a single day of laboratory synthesis. That is exactly what the expensive quantum tier is for — cheap insurance against making the wrong molecule.</a:t>
+            </a:r>
+          </a:p>
+        </p:txBody>
+      </p:sp>
+      <p:sp>
+        <p:nvSpPr>
+          <p:cNvPr id="4" name="Slide Number Placeholder 3"/>
+          <p:cNvSpPr>
+            <a:spLocks noGrp="1"/>
+          </p:cNvSpPr>
+          <p:nvPr>
+            <p:ph type="sldNum" idx="5" sz="quarter"/>
+          </p:nvPr>
+        </p:nvSpPr>
+        <p:spPr/>
+      </p:sp>
+    </p:spTree>
+  </p:cSld>
+  <p:clrMapOvr>
+    <a:masterClrMapping/>
+  </p:clrMapOvr>
+</p:notes>
+</file>
+
+<file path=ppt/notesSlides/notesSlide14.xml><?xml version="1.0" encoding="utf-8"?>
+<p:notes xmlns:a="http://schemas.openxmlformats.org/drawingml/2006/main" xmlns:p="http://schemas.openxmlformats.org/presentationml/2006/main" xmlns:r="http://schemas.openxmlformats.org/officeDocument/2006/relationships">
+  <p:cSld>
+    <p:spTree>
+      <p:nvGrpSpPr>
+        <p:cNvPr id="1" name=""/>
+        <p:cNvGrpSpPr/>
+        <p:nvPr/>
+      </p:nvGrpSpPr>
+      <p:grpSpPr>
+        <a:xfrm>
+          <a:off x="0" y="0"/>
+          <a:ext cx="0" cy="0"/>
+          <a:chOff x="0" y="0"/>
+          <a:chExt cx="0" cy="0"/>
+        </a:xfrm>
+      </p:grpSpPr>
+      <p:sp>
+        <p:nvSpPr>
+          <p:cNvPr id="2" name="Slide Image Placeholder 1"/>
+          <p:cNvSpPr>
+            <a:spLocks noGrp="1"/>
+          </p:cNvSpPr>
+          <p:nvPr>
+            <p:ph type="sldImg" idx="2"/>
+          </p:nvPr>
+        </p:nvSpPr>
+        <p:spPr/>
+      </p:sp>
+      <p:sp>
+        <p:nvSpPr>
+          <p:cNvPr id="3" name="Notes Placeholder 2"/>
+          <p:cNvSpPr>
+            <a:spLocks noGrp="1"/>
+          </p:cNvSpPr>
+          <p:nvPr>
+            <p:ph type="body" idx="3" sz="quarter"/>
+          </p:nvPr>
+        </p:nvSpPr>
+        <p:spPr/>
+        <p:txBody>
+          <a:bodyPr/>
+          <a:lstStyle/>
+          <a:p>
+            <a:r>
+              <a:t>[~55s] So computation told us the water-friendly route was a dead end — and the approved-drug lesson told us the right route instead: don't make the tail water-friendly, make it less rigid. This is our deliverable: a short, ranked set of molecules that keep the tail the same length — so potency is preserved — and change only its shape, from rigid to flexible. And here is the practical gift: these are also the easiest molecules to make — cheap, off-the-shelf building blocks, one step — unlike the original or the exotic designs. So the best scientific bet and the cheapest chemistry are the same molecules. We make the flexible ones first.</a:t>
+            </a:r>
+          </a:p>
+        </p:txBody>
+      </p:sp>
+      <p:sp>
+        <p:nvSpPr>
+          <p:cNvPr id="4" name="Slide Number Placeholder 3"/>
+          <p:cNvSpPr>
+            <a:spLocks noGrp="1"/>
+          </p:cNvSpPr>
+          <p:nvPr>
+            <p:ph type="sldNum" idx="5" sz="quarter"/>
+          </p:nvPr>
+        </p:nvSpPr>
+        <p:spPr/>
+      </p:sp>
+    </p:spTree>
+  </p:cSld>
+  <p:clrMapOvr>
+    <a:masterClrMapping/>
+  </p:clrMapOvr>
+</p:notes>
+</file>
+
+<file path=ppt/notesSlides/notesSlide15.xml><?xml version="1.0" encoding="utf-8"?>
+<p:notes xmlns:a="http://schemas.openxmlformats.org/drawingml/2006/main" xmlns:p="http://schemas.openxmlformats.org/presentationml/2006/main" xmlns:r="http://schemas.openxmlformats.org/officeDocument/2006/relationships">
+  <p:cSld>
+    <p:spTree>
+      <p:nvGrpSpPr>
+        <p:cNvPr id="1" name=""/>
+        <p:cNvGrpSpPr/>
+        <p:nvPr/>
+      </p:nvGrpSpPr>
+      <p:grpSpPr>
+        <a:xfrm>
+          <a:off x="0" y="0"/>
+          <a:ext cx="0" cy="0"/>
+          <a:chOff x="0" y="0"/>
+          <a:chExt cx="0" cy="0"/>
+        </a:xfrm>
+      </p:grpSpPr>
+      <p:sp>
+        <p:nvSpPr>
+          <p:cNvPr id="2" name="Slide Image Placeholder 1"/>
+          <p:cNvSpPr>
+            <a:spLocks noGrp="1"/>
+          </p:cNvSpPr>
+          <p:nvPr>
+            <p:ph type="sldImg" idx="2"/>
+          </p:nvPr>
+        </p:nvSpPr>
+        <p:spPr/>
+      </p:sp>
+      <p:sp>
+        <p:nvSpPr>
+          <p:cNvPr id="3" name="Notes Placeholder 2"/>
+          <p:cNvSpPr>
+            <a:spLocks noGrp="1"/>
+          </p:cNvSpPr>
+          <p:nvPr>
+            <p:ph type="body" idx="3" sz="quarter"/>
+          </p:nvPr>
+        </p:nvSpPr>
+        <p:spPr/>
+        <p:txBody>
+          <a:bodyPr/>
+          <a:lstStyle/>
+          <a:p>
+            <a:r>
+              <a:t>[~50s] Stepping back, here is what the program delivered — and I want to stress it is a platform, not a one-off. A curated benchmark dataset that is a resource for the field. A validated quantum-chemistry method for these large, floppy natural products, which is genuinely hard. An AI generator with a scoring rule checked against real data. A framework for importing clinical drug knowledge into design. Reproducible engineering — documented stages, automated tests, run scripts — so anyone can rebuild it. And a clear roadmap with a concrete shortlist. Any one of these outlives the specific question we started with.</a:t>
+            </a:r>
+          </a:p>
+        </p:txBody>
+      </p:sp>
+      <p:sp>
+        <p:nvSpPr>
+          <p:cNvPr id="4" name="Slide Number Placeholder 3"/>
+          <p:cNvSpPr>
+            <a:spLocks noGrp="1"/>
+          </p:cNvSpPr>
+          <p:nvPr>
+            <p:ph type="sldNum" idx="5" sz="quarter"/>
+          </p:nvPr>
+        </p:nvSpPr>
+        <p:spPr/>
+      </p:sp>
+    </p:spTree>
+  </p:cSld>
+  <p:clrMapOvr>
+    <a:masterClrMapping/>
+  </p:clrMapOvr>
+</p:notes>
+</file>
+
+<file path=ppt/notesSlides/notesSlide16.xml><?xml version="1.0" encoding="utf-8"?>
+<p:notes xmlns:a="http://schemas.openxmlformats.org/drawingml/2006/main" xmlns:p="http://schemas.openxmlformats.org/presentationml/2006/main" xmlns:r="http://schemas.openxmlformats.org/officeDocument/2006/relationships">
+  <p:cSld>
+    <p:spTree>
+      <p:nvGrpSpPr>
+        <p:cNvPr id="1" name=""/>
+        <p:cNvGrpSpPr/>
+        <p:nvPr/>
+      </p:nvGrpSpPr>
+      <p:grpSpPr>
+        <a:xfrm>
+          <a:off x="0" y="0"/>
+          <a:ext cx="0" cy="0"/>
+          <a:chOff x="0" y="0"/>
+          <a:chExt cx="0" cy="0"/>
+        </a:xfrm>
+      </p:grpSpPr>
+      <p:sp>
+        <p:nvSpPr>
+          <p:cNvPr id="2" name="Slide Image Placeholder 1"/>
+          <p:cNvSpPr>
+            <a:spLocks noGrp="1"/>
+          </p:cNvSpPr>
+          <p:nvPr>
+            <p:ph type="sldImg" idx="2"/>
+          </p:nvPr>
+        </p:nvSpPr>
+        <p:spPr/>
+      </p:sp>
+      <p:sp>
+        <p:nvSpPr>
+          <p:cNvPr id="3" name="Notes Placeholder 2"/>
+          <p:cNvSpPr>
+            <a:spLocks noGrp="1"/>
+          </p:cNvSpPr>
+          <p:nvPr>
+            <p:ph type="body" idx="3" sz="quarter"/>
+          </p:nvPr>
+        </p:nvSpPr>
+        <p:spPr/>
+        <p:txBody>
+          <a:bodyPr/>
+          <a:lstStyle/>
+          <a:p>
+            <a:r>
+              <a:t>[~55s] I want to be direct about the honest conclusion, because it is often misunderstood. This is not 'AI failed.' It is a precise statement of the critical path: AI drug design needs a measured answer key to learn from, and we showed — rigorously — that physics-based guesses alone can mislead. The good news is we now know exactly which few experiments unlock the predictive AI, and the AI is already built to use them. The loop at the bottom is the path: synthesize the four-molecule shortlist, measure their serum behavior, feed that back to train the AI, and let it design the next, wider round. Each turn makes the AI a better designer — and the immediate next step needs no more computing, just a lab experiment.</a:t>
+            </a:r>
+          </a:p>
+        </p:txBody>
+      </p:sp>
+      <p:sp>
+        <p:nvSpPr>
+          <p:cNvPr id="4" name="Slide Number Placeholder 3"/>
+          <p:cNvSpPr>
+            <a:spLocks noGrp="1"/>
+          </p:cNvSpPr>
+          <p:nvPr>
+            <p:ph type="sldNum" idx="5" sz="quarter"/>
+          </p:nvPr>
+        </p:nvSpPr>
+        <p:spPr/>
+      </p:sp>
+    </p:spTree>
+  </p:cSld>
+  <p:clrMapOvr>
+    <a:masterClrMapping/>
+  </p:clrMapOvr>
+</p:notes>
+</file>
+
+<file path=ppt/notesSlides/notesSlide17.xml><?xml version="1.0" encoding="utf-8"?>
+<p:notes xmlns:a="http://schemas.openxmlformats.org/drawingml/2006/main" xmlns:p="http://schemas.openxmlformats.org/presentationml/2006/main" xmlns:r="http://schemas.openxmlformats.org/officeDocument/2006/relationships">
+  <p:cSld>
+    <p:spTree>
+      <p:nvGrpSpPr>
+        <p:cNvPr id="1" name=""/>
+        <p:cNvGrpSpPr/>
+        <p:nvPr/>
+      </p:nvGrpSpPr>
+      <p:grpSpPr>
+        <a:xfrm>
+          <a:off x="0" y="0"/>
+          <a:ext cx="0" cy="0"/>
+          <a:chOff x="0" y="0"/>
+          <a:chExt cx="0" cy="0"/>
+        </a:xfrm>
+      </p:grpSpPr>
+      <p:sp>
+        <p:nvSpPr>
+          <p:cNvPr id="2" name="Slide Image Placeholder 1"/>
+          <p:cNvSpPr>
+            <a:spLocks noGrp="1"/>
+          </p:cNvSpPr>
+          <p:nvPr>
+            <p:ph type="sldImg" idx="2"/>
+          </p:nvPr>
+        </p:nvSpPr>
+        <p:spPr/>
+      </p:sp>
+      <p:sp>
+        <p:nvSpPr>
+          <p:cNvPr id="3" name="Notes Placeholder 2"/>
+          <p:cNvSpPr>
+            <a:spLocks noGrp="1"/>
+          </p:cNvSpPr>
+          <p:nvPr>
+            <p:ph type="body" idx="3" sz="quarter"/>
+          </p:nvPr>
+        </p:nvSpPr>
+        <p:spPr/>
+        <p:txBody>
+          <a:bodyPr/>
+          <a:lstStyle/>
+          <a:p>
+            <a:r>
+              <a:t>[~55s] To summarize the significance. We took a stalled but high-value drug class and turned it into a tractable design problem. We built an end-to-end AI-plus-quantum-chemistry platform that is reusable. We demonstrated rigorous self-correction — the honesty ladder — which is really the hallmark of trustworthy science. The work spans chemistry, machine learning, quantum physics, and clinical pharmacology. And we defined the exact experiment that unlocks predictive AI, which de-risks future investment. If I leave you with one line: we set out to teach a computer to design a serum-tolerant antifungal — and along the way we learned to tell a real signal from a flattering illusion. The computer is ready; it is waiting for one clean experiment, narrowed to exactly four molecules.</a:t>
+            </a:r>
+          </a:p>
+        </p:txBody>
+      </p:sp>
+      <p:sp>
+        <p:nvSpPr>
+          <p:cNvPr id="4" name="Slide Number Placeholder 3"/>
+          <p:cNvSpPr>
+            <a:spLocks noGrp="1"/>
+          </p:cNvSpPr>
+          <p:nvPr>
+            <p:ph type="sldNum" idx="5" sz="quarter"/>
+          </p:nvPr>
+        </p:nvSpPr>
+        <p:spPr/>
+      </p:sp>
+    </p:spTree>
+  </p:cSld>
+  <p:clrMapOvr>
+    <a:masterClrMapping/>
+  </p:clrMapOvr>
+</p:notes>
+</file>
+
+<file path=ppt/notesSlides/notesSlide18.xml><?xml version="1.0" encoding="utf-8"?>
+<p:notes xmlns:a="http://schemas.openxmlformats.org/drawingml/2006/main" xmlns:p="http://schemas.openxmlformats.org/presentationml/2006/main" xmlns:r="http://schemas.openxmlformats.org/officeDocument/2006/relationships">
+  <p:cSld>
+    <p:spTree>
+      <p:nvGrpSpPr>
+        <p:cNvPr id="1" name=""/>
+        <p:cNvGrpSpPr/>
+        <p:nvPr/>
+      </p:nvGrpSpPr>
+      <p:grpSpPr>
+        <a:xfrm>
+          <a:off x="0" y="0"/>
+          <a:ext cx="0" cy="0"/>
+          <a:chOff x="0" y="0"/>
+          <a:chExt cx="0" cy="0"/>
+        </a:xfrm>
+      </p:grpSpPr>
+      <p:sp>
+        <p:nvSpPr>
+          <p:cNvPr id="2" name="Slide Image Placeholder 1"/>
+          <p:cNvSpPr>
+            <a:spLocks noGrp="1"/>
+          </p:cNvSpPr>
+          <p:nvPr>
+            <p:ph type="sldImg" idx="2"/>
+          </p:nvPr>
+        </p:nvSpPr>
+        <p:spPr/>
+      </p:sp>
+      <p:sp>
+        <p:nvSpPr>
+          <p:cNvPr id="3" name="Notes Placeholder 2"/>
+          <p:cNvSpPr>
+            <a:spLocks noGrp="1"/>
+          </p:cNvSpPr>
+          <p:nvPr>
+            <p:ph type="body" idx="3" sz="quarter"/>
+          </p:nvPr>
+        </p:nvSpPr>
+        <p:spPr/>
+        <p:txBody>
+          <a:bodyPr/>
+          <a:lstStyle/>
+          <a:p>
+            <a:r>
+              <a:t>[~20s] Thank you. I am happy to take questions — about the biology, the computational methods, the AI, or where this goes next. All the detail, the code, and the reproducible reports live in the project repository, so anything I show can be independently checked.</a:t>
+            </a:r>
+          </a:p>
+        </p:txBody>
+      </p:sp>
+      <p:sp>
+        <p:nvSpPr>
+          <p:cNvPr id="4" name="Slide Number Placeholder 3"/>
+          <p:cNvSpPr>
+            <a:spLocks noGrp="1"/>
+          </p:cNvSpPr>
+          <p:nvPr>
+            <p:ph type="sldNum" idx="5" sz="quarter"/>
+          </p:nvPr>
+        </p:nvSpPr>
+        <p:spPr/>
+      </p:sp>
+    </p:spTree>
+  </p:cSld>
+  <p:clrMapOvr>
+    <a:masterClrMapping/>
+  </p:clrMapOvr>
+</p:notes>
+</file>
+
+<file path=ppt/notesSlides/notesSlide2.xml><?xml version="1.0" encoding="utf-8"?>
+<p:notes xmlns:a="http://schemas.openxmlformats.org/drawingml/2006/main" xmlns:p="http://schemas.openxmlformats.org/presentationml/2006/main" xmlns:r="http://schemas.openxmlformats.org/officeDocument/2006/relationships">
+  <p:cSld>
+    <p:spTree>
+      <p:nvGrpSpPr>
+        <p:cNvPr id="1" name=""/>
+        <p:cNvGrpSpPr/>
+        <p:nvPr/>
+      </p:nvGrpSpPr>
+      <p:grpSpPr>
+        <a:xfrm>
+          <a:off x="0" y="0"/>
+          <a:ext cx="0" cy="0"/>
+          <a:chOff x="0" y="0"/>
+          <a:chExt cx="0" cy="0"/>
+        </a:xfrm>
+      </p:grpSpPr>
+      <p:sp>
+        <p:nvSpPr>
+          <p:cNvPr id="2" name="Slide Image Placeholder 1"/>
+          <p:cNvSpPr>
+            <a:spLocks noGrp="1"/>
+          </p:cNvSpPr>
+          <p:nvPr>
+            <p:ph type="sldImg" idx="2"/>
+          </p:nvPr>
+        </p:nvSpPr>
+        <p:spPr/>
+      </p:sp>
+      <p:sp>
+        <p:nvSpPr>
+          <p:cNvPr id="3" name="Notes Placeholder 2"/>
+          <p:cNvSpPr>
+            <a:spLocks noGrp="1"/>
+          </p:cNvSpPr>
+          <p:nvPr>
+            <p:ph type="body" idx="3" sz="quarter"/>
+          </p:nvPr>
+        </p:nvSpPr>
+        <p:spPr/>
+        <p:txBody>
+          <a:bodyPr/>
+          <a:lstStyle/>
+          <a:p>
+            <a:r>
+              <a:t>[~60s] Invasive fungal infections are a growing, under-appreciated threat — they kill hundreds of thousands of people a year, often patients whose immune systems are already compromised. Yet we have only a handful of antifungal drug classes, many with serious side effects, and resistance is spreading. So there is a real need for genuinely new structures. Our starting point is a natural-product family, the papulacandins. They hit a target that is attractive because it is in the fungus but not in us — the machinery that builds the fungal cell wall. The catch, in red: these molecules are potent in a test tube but lose activity in blood serum. That single flaw is why they never became drugs. If we can understand and fix it, we potentially revive an entire class.</a:t>
+            </a:r>
+          </a:p>
+        </p:txBody>
+      </p:sp>
+      <p:sp>
+        <p:nvSpPr>
+          <p:cNvPr id="4" name="Slide Number Placeholder 3"/>
+          <p:cNvSpPr>
+            <a:spLocks noGrp="1"/>
+          </p:cNvSpPr>
+          <p:nvPr>
+            <p:ph type="sldNum" idx="5" sz="quarter"/>
+          </p:nvPr>
+        </p:nvSpPr>
+        <p:spPr/>
+      </p:sp>
+    </p:spTree>
+  </p:cSld>
+  <p:clrMapOvr>
+    <a:masterClrMapping/>
+  </p:clrMapOvr>
+</p:notes>
+</file>
+
+<file path=ppt/notesSlides/notesSlide3.xml><?xml version="1.0" encoding="utf-8"?>
+<p:notes xmlns:a="http://schemas.openxmlformats.org/drawingml/2006/main" xmlns:p="http://schemas.openxmlformats.org/presentationml/2006/main" xmlns:r="http://schemas.openxmlformats.org/officeDocument/2006/relationships">
+  <p:cSld>
+    <p:spTree>
+      <p:nvGrpSpPr>
+        <p:cNvPr id="1" name=""/>
+        <p:cNvGrpSpPr/>
+        <p:nvPr/>
+      </p:nvGrpSpPr>
+      <p:grpSpPr>
+        <a:xfrm>
+          <a:off x="0" y="0"/>
+          <a:ext cx="0" cy="0"/>
+          <a:chOff x="0" y="0"/>
+          <a:chExt cx="0" cy="0"/>
+        </a:xfrm>
+      </p:grpSpPr>
+      <p:sp>
+        <p:nvSpPr>
+          <p:cNvPr id="2" name="Slide Image Placeholder 1"/>
+          <p:cNvSpPr>
+            <a:spLocks noGrp="1"/>
+          </p:cNvSpPr>
+          <p:nvPr>
+            <p:ph type="sldImg" idx="2"/>
+          </p:nvPr>
+        </p:nvSpPr>
+        <p:spPr/>
+      </p:sp>
+      <p:sp>
+        <p:nvSpPr>
+          <p:cNvPr id="3" name="Notes Placeholder 2"/>
+          <p:cNvSpPr>
+            <a:spLocks noGrp="1"/>
+          </p:cNvSpPr>
+          <p:nvPr>
+            <p:ph type="body" idx="3" sz="quarter"/>
+          </p:nvPr>
+        </p:nvSpPr>
+        <p:spPr/>
+        <p:txBody>
+          <a:bodyPr/>
+          <a:lstStyle/>
+          <a:p>
+            <a:r>
+              <a:t>[~45s] Before any modeling we had to build the dataset. The results we needed were scattered across decades of old papers, so we hand-curated them into one clean, computer-readable database — 138 compounds and over a thousand activity measurements, each traceable to its source. The heart of it is the 24 compounds with the matched measurement we care about: activity with and without serum. Thirteen keep some activity; eleven are switched off completely. We later imported an independent set of data on approved drugs for cross-checking. I want to flag that this curated dataset is itself a lasting contribution — it is the benchmark everything else is measured against, and others can reuse it.</a:t>
+            </a:r>
+          </a:p>
+        </p:txBody>
+      </p:sp>
+      <p:sp>
+        <p:nvSpPr>
+          <p:cNvPr id="4" name="Slide Number Placeholder 3"/>
+          <p:cNvSpPr>
+            <a:spLocks noGrp="1"/>
+          </p:cNvSpPr>
+          <p:nvPr>
+            <p:ph type="sldNum" idx="5" sz="quarter"/>
+          </p:nvPr>
+        </p:nvSpPr>
+        <p:spPr/>
+      </p:sp>
+    </p:spTree>
+  </p:cSld>
+  <p:clrMapOvr>
+    <a:masterClrMapping/>
+  </p:clrMapOvr>
+</p:notes>
+</file>
+
+<file path=ppt/notesSlides/notesSlide4.xml><?xml version="1.0" encoding="utf-8"?>
+<p:notes xmlns:a="http://schemas.openxmlformats.org/drawingml/2006/main" xmlns:p="http://schemas.openxmlformats.org/presentationml/2006/main" xmlns:r="http://schemas.openxmlformats.org/officeDocument/2006/relationships">
+  <p:cSld>
+    <p:spTree>
+      <p:nvGrpSpPr>
+        <p:cNvPr id="1" name=""/>
+        <p:cNvGrpSpPr/>
+        <p:nvPr/>
+      </p:nvGrpSpPr>
+      <p:grpSpPr>
+        <a:xfrm>
+          <a:off x="0" y="0"/>
+          <a:ext cx="0" cy="0"/>
+          <a:chOff x="0" y="0"/>
+          <a:chExt cx="0" cy="0"/>
+        </a:xfrm>
+      </p:grpSpPr>
+      <p:sp>
+        <p:nvSpPr>
+          <p:cNvPr id="2" name="Slide Image Placeholder 1"/>
+          <p:cNvSpPr>
+            <a:spLocks noGrp="1"/>
+          </p:cNvSpPr>
+          <p:nvPr>
+            <p:ph type="sldImg" idx="2"/>
+          </p:nvPr>
+        </p:nvSpPr>
+        <p:spPr/>
+      </p:sp>
+      <p:sp>
+        <p:nvSpPr>
+          <p:cNvPr id="3" name="Notes Placeholder 2"/>
+          <p:cNvSpPr>
+            <a:spLocks noGrp="1"/>
+          </p:cNvSpPr>
+          <p:nvPr>
+            <p:ph type="body" idx="3" sz="quarter"/>
+          </p:nvPr>
+        </p:nvSpPr>
+        <p:spPr/>
+        <p:txBody>
+          <a:bodyPr/>
+          <a:lstStyle/>
+          <a:p>
+            <a:r>
+              <a:t>[~50s] This is the problem in one picture. Every horizontal line is one compound. The blue dot on the left is the dose needed to stop the fungus in clean broth — low, meaning potent. Follow the line right to the dose needed in serum. Green compounds keep reasonable activity; the red arrows are compounds pushed past our detection ceiling — serum has essentially abolished them. The gap between the two ends is what we named the 'serum shift': serum dose divided by broth dose. A shift near one is ideal; a large shift is the clinical failure. Everything downstream is about lowering that shift without giving up potency. So the whole project reduces to one number we are trying to design down.</a:t>
+            </a:r>
+          </a:p>
+        </p:txBody>
+      </p:sp>
+      <p:sp>
+        <p:nvSpPr>
+          <p:cNvPr id="4" name="Slide Number Placeholder 3"/>
+          <p:cNvSpPr>
+            <a:spLocks noGrp="1"/>
+          </p:cNvSpPr>
+          <p:nvPr>
+            <p:ph type="sldNum" idx="5" sz="quarter"/>
+          </p:nvPr>
+        </p:nvSpPr>
+        <p:spPr/>
+      </p:sp>
+    </p:spTree>
+  </p:cSld>
+  <p:clrMapOvr>
+    <a:masterClrMapping/>
+  </p:clrMapOvr>
+</p:notes>
+</file>
+
+<file path=ppt/notesSlides/notesSlide5.xml><?xml version="1.0" encoding="utf-8"?>
+<p:notes xmlns:a="http://schemas.openxmlformats.org/drawingml/2006/main" xmlns:p="http://schemas.openxmlformats.org/presentationml/2006/main" xmlns:r="http://schemas.openxmlformats.org/officeDocument/2006/relationships">
+  <p:cSld>
+    <p:spTree>
+      <p:nvGrpSpPr>
+        <p:cNvPr id="1" name=""/>
+        <p:cNvGrpSpPr/>
+        <p:nvPr/>
+      </p:nvGrpSpPr>
+      <p:grpSpPr>
+        <a:xfrm>
+          <a:off x="0" y="0"/>
+          <a:ext cx="0" cy="0"/>
+          <a:chOff x="0" y="0"/>
+          <a:chExt cx="0" cy="0"/>
+        </a:xfrm>
+      </p:grpSpPr>
+      <p:sp>
+        <p:nvSpPr>
+          <p:cNvPr id="2" name="Slide Image Placeholder 1"/>
+          <p:cNvSpPr>
+            <a:spLocks noGrp="1"/>
+          </p:cNvSpPr>
+          <p:nvPr>
+            <p:ph type="sldImg" idx="2"/>
+          </p:nvPr>
+        </p:nvSpPr>
+        <p:spPr/>
+      </p:sp>
+      <p:sp>
+        <p:nvSpPr>
+          <p:cNvPr id="3" name="Notes Placeholder 2"/>
+          <p:cNvSpPr>
+            <a:spLocks noGrp="1"/>
+          </p:cNvSpPr>
+          <p:nvPr>
+            <p:ph type="body" idx="3" sz="quarter"/>
+          </p:nvPr>
+        </p:nvSpPr>
+        <p:spPr/>
+        <p:txBody>
+          <a:bodyPr/>
+          <a:lstStyle/>
+          <a:p>
+            <a:r>
+              <a:t>[~45s] Here is the overall strategy. Rather than one big experiment, we built a staged funnel across four acts and fourteen documented steps. We start broad and cheap — curating data and looking for simple patterns. Then we go three-dimensional with quantum chemistry. Then — and this turned out to be pivotal — we borrow lessons from approved drugs. And finally we let AI design molecules and stress-test them. The key discipline, shown by the narrowing shape, is that each stage checks our reasoning before we spend effort on the next. And because it is all documented and reproducible, the platform outlives this one question.</a:t>
+            </a:r>
+          </a:p>
+        </p:txBody>
+      </p:sp>
+      <p:sp>
+        <p:nvSpPr>
+          <p:cNvPr id="4" name="Slide Number Placeholder 3"/>
+          <p:cNvSpPr>
+            <a:spLocks noGrp="1"/>
+          </p:cNvSpPr>
+          <p:nvPr>
+            <p:ph type="sldNum" idx="5" sz="quarter"/>
+          </p:nvPr>
+        </p:nvSpPr>
+        <p:spPr/>
+      </p:sp>
+    </p:spTree>
+  </p:cSld>
+  <p:clrMapOvr>
+    <a:masterClrMapping/>
+  </p:clrMapOvr>
+</p:notes>
+</file>
+
+<file path=ppt/notesSlides/notesSlide6.xml><?xml version="1.0" encoding="utf-8"?>
+<p:notes xmlns:a="http://schemas.openxmlformats.org/drawingml/2006/main" xmlns:p="http://schemas.openxmlformats.org/presentationml/2006/main" xmlns:r="http://schemas.openxmlformats.org/officeDocument/2006/relationships">
+  <p:cSld>
+    <p:spTree>
+      <p:nvGrpSpPr>
+        <p:cNvPr id="1" name=""/>
+        <p:cNvGrpSpPr/>
+        <p:nvPr/>
+      </p:nvGrpSpPr>
+      <p:grpSpPr>
+        <a:xfrm>
+          <a:off x="0" y="0"/>
+          <a:ext cx="0" cy="0"/>
+          <a:chOff x="0" y="0"/>
+          <a:chExt cx="0" cy="0"/>
+        </a:xfrm>
+      </p:grpSpPr>
+      <p:sp>
+        <p:nvSpPr>
+          <p:cNvPr id="2" name="Slide Image Placeholder 1"/>
+          <p:cNvSpPr>
+            <a:spLocks noGrp="1"/>
+          </p:cNvSpPr>
+          <p:nvPr>
+            <p:ph type="sldImg" idx="2"/>
+          </p:nvPr>
+        </p:nvSpPr>
+        <p:spPr/>
+      </p:sp>
+      <p:sp>
+        <p:nvSpPr>
+          <p:cNvPr id="3" name="Notes Placeholder 2"/>
+          <p:cNvSpPr>
+            <a:spLocks noGrp="1"/>
+          </p:cNvSpPr>
+          <p:nvPr>
+            <p:ph type="body" idx="3" sz="quarter"/>
+          </p:nvPr>
+        </p:nvSpPr>
+        <p:spPr/>
+        <p:txBody>
+          <a:bodyPr/>
+          <a:lstStyle/>
+          <a:p>
+            <a:r>
+              <a:t>[~55s] This is the engine at the heart of Act Two — the 'algorithm', in plain terms. These molecules are floppy; think of a piece of cooked spaghetti that curls into many shapes. To judge them fairly we compute the real 3-D shapes they adopt in water and measure how much greasy versus water-friendly surface they expose. The trick is cost: each tier down the funnel is more accurate and more expensive. So we generate many molecules, filter cheaply, and spend the costly quantum methods only on the few survivors — using the same measurement engine at every tier so comparisons stay fair. This funnel is reusable infrastructure, not specific to this one question.</a:t>
+            </a:r>
+          </a:p>
+        </p:txBody>
+      </p:sp>
+      <p:sp>
+        <p:nvSpPr>
+          <p:cNvPr id="4" name="Slide Number Placeholder 3"/>
+          <p:cNvSpPr>
+            <a:spLocks noGrp="1"/>
+          </p:cNvSpPr>
+          <p:nvPr>
+            <p:ph type="sldNum" idx="5" sz="quarter"/>
+          </p:nvPr>
+        </p:nvSpPr>
+        <p:spPr/>
+      </p:sp>
+    </p:spTree>
+  </p:cSld>
+  <p:clrMapOvr>
+    <a:masterClrMapping/>
+  </p:clrMapOvr>
+</p:notes>
+</file>
+
+<file path=ppt/notesSlides/notesSlide7.xml><?xml version="1.0" encoding="utf-8"?>
+<p:notes xmlns:a="http://schemas.openxmlformats.org/drawingml/2006/main" xmlns:p="http://schemas.openxmlformats.org/presentationml/2006/main" xmlns:r="http://schemas.openxmlformats.org/officeDocument/2006/relationships">
+  <p:cSld>
+    <p:spTree>
+      <p:nvGrpSpPr>
+        <p:cNvPr id="1" name=""/>
+        <p:cNvGrpSpPr/>
+        <p:nvPr/>
+      </p:nvGrpSpPr>
+      <p:grpSpPr>
+        <a:xfrm>
+          <a:off x="0" y="0"/>
+          <a:ext cx="0" cy="0"/>
+          <a:chOff x="0" y="0"/>
+          <a:chExt cx="0" cy="0"/>
+        </a:xfrm>
+      </p:grpSpPr>
+      <p:sp>
+        <p:nvSpPr>
+          <p:cNvPr id="2" name="Slide Image Placeholder 1"/>
+          <p:cNvSpPr>
+            <a:spLocks noGrp="1"/>
+          </p:cNvSpPr>
+          <p:nvPr>
+            <p:ph type="sldImg" idx="2"/>
+          </p:nvPr>
+        </p:nvSpPr>
+        <p:spPr/>
+      </p:sp>
+      <p:sp>
+        <p:nvSpPr>
+          <p:cNvPr id="3" name="Notes Placeholder 2"/>
+          <p:cNvSpPr>
+            <a:spLocks noGrp="1"/>
+          </p:cNvSpPr>
+          <p:nvPr>
+            <p:ph type="body" idx="3" sz="quarter"/>
+          </p:nvPr>
+        </p:nvSpPr>
+        <p:spPr/>
+        <p:txBody>
+          <a:bodyPr/>
+          <a:lstStyle/>
+          <a:p>
+            <a:r>
+              <a:t>[~70s — the key slide] This is the most important methodological slide and the strongest evidence of how we work. The vertical axis is the strength of the apparent signal linking our 3-D descriptor to serum tolerance; read left to right as we increase rigor. Crude 2-D chemistry: weak. A cheap 3-D method: it looks strong — genuinely tempting, you could write a paper on that bar. But accurate quantum chemistry shrank it, and once we did the honest thing and controlled for plain potency, it collapsed to essentially zero. The exciting early result was largely an illusion. The message: at every rung, a less careful analysis would have made a confident and wrong claim. We climbed the whole ladder and reported what was actually there. Knowing precisely what is not true is a real, durable result — and it is what stops us wasting years chasing a mirage. [If asked 'so you found nothing?': we found what is NOT true — which saves years — plus one honest lead and a validated platform. Rigorously established negatives are results.]</a:t>
+            </a:r>
+          </a:p>
+        </p:txBody>
+      </p:sp>
+      <p:sp>
+        <p:nvSpPr>
+          <p:cNvPr id="4" name="Slide Number Placeholder 3"/>
+          <p:cNvSpPr>
+            <a:spLocks noGrp="1"/>
+          </p:cNvSpPr>
+          <p:nvPr>
+            <p:ph type="sldNum" idx="5" sz="quarter"/>
+          </p:nvPr>
+        </p:nvSpPr>
+        <p:spPr/>
+      </p:sp>
+    </p:spTree>
+  </p:cSld>
+  <p:clrMapOvr>
+    <a:masterClrMapping/>
+  </p:clrMapOvr>
+</p:notes>
+</file>
+
+<file path=ppt/notesSlides/notesSlide8.xml><?xml version="1.0" encoding="utf-8"?>
+<p:notes xmlns:a="http://schemas.openxmlformats.org/drawingml/2006/main" xmlns:p="http://schemas.openxmlformats.org/presentationml/2006/main" xmlns:r="http://schemas.openxmlformats.org/officeDocument/2006/relationships">
+  <p:cSld>
+    <p:spTree>
+      <p:nvGrpSpPr>
+        <p:cNvPr id="1" name=""/>
+        <p:cNvGrpSpPr/>
+        <p:nvPr/>
+      </p:nvGrpSpPr>
+      <p:grpSpPr>
+        <a:xfrm>
+          <a:off x="0" y="0"/>
+          <a:ext cx="0" cy="0"/>
+          <a:chOff x="0" y="0"/>
+          <a:chExt cx="0" cy="0"/>
+        </a:xfrm>
+      </p:grpSpPr>
+      <p:sp>
+        <p:nvSpPr>
+          <p:cNvPr id="2" name="Slide Image Placeholder 1"/>
+          <p:cNvSpPr>
+            <a:spLocks noGrp="1"/>
+          </p:cNvSpPr>
+          <p:nvPr>
+            <p:ph type="sldImg" idx="2"/>
+          </p:nvPr>
+        </p:nvSpPr>
+        <p:spPr/>
+      </p:sp>
+      <p:sp>
+        <p:nvSpPr>
+          <p:cNvPr id="3" name="Notes Placeholder 2"/>
+          <p:cNvSpPr>
+            <a:spLocks noGrp="1"/>
+          </p:cNvSpPr>
+          <p:nvPr>
+            <p:ph type="body" idx="3" sz="quarter"/>
+          </p:nvPr>
+        </p:nvSpPr>
+        <p:spPr/>
+        <p:txBody>
+          <a:bodyPr/>
+          <a:lstStyle/>
+          <a:p>
+            <a:r>
+              <a:t>[~55s] Here is the data behind that collapse — the decisive check. On the left, the dose needed in serum plotted against the dose needed in broth. They track together tightly, correlation 0.79. In plain terms, a compound's fate in serum is mostly explained by how potent it was to begin with, not by a special serum-resistance property. On the right, once we statistically remove that potency effect, the 3-D descriptor that looked so promising — the greasy-surface one — drops to essentially zero. Only one weak signal survives: exposing water-friendly rather than greasy surface. That survivor is faint, but it is the honest lead we carried forward. This is what separates a real effect from a potency artifact.</a:t>
+            </a:r>
+          </a:p>
+        </p:txBody>
+      </p:sp>
+      <p:sp>
+        <p:nvSpPr>
+          <p:cNvPr id="4" name="Slide Number Placeholder 3"/>
+          <p:cNvSpPr>
+            <a:spLocks noGrp="1"/>
+          </p:cNvSpPr>
+          <p:nvPr>
+            <p:ph type="sldNum" idx="5" sz="quarter"/>
+          </p:nvPr>
+        </p:nvSpPr>
+        <p:spPr/>
+      </p:sp>
+    </p:spTree>
+  </p:cSld>
+  <p:clrMapOvr>
+    <a:masterClrMapping/>
+  </p:clrMapOvr>
+</p:notes>
+</file>
+
+<file path=ppt/notesSlides/notesSlide9.xml><?xml version="1.0" encoding="utf-8"?>
+<p:notes xmlns:a="http://schemas.openxmlformats.org/drawingml/2006/main" xmlns:p="http://schemas.openxmlformats.org/presentationml/2006/main" xmlns:r="http://schemas.openxmlformats.org/officeDocument/2006/relationships">
+  <p:cSld>
+    <p:spTree>
+      <p:nvGrpSpPr>
+        <p:cNvPr id="1" name=""/>
+        <p:cNvGrpSpPr/>
+        <p:nvPr/>
+      </p:nvGrpSpPr>
+      <p:grpSpPr>
+        <a:xfrm>
+          <a:off x="0" y="0"/>
+          <a:ext cx="0" cy="0"/>
+          <a:chOff x="0" y="0"/>
+          <a:chExt cx="0" cy="0"/>
+        </a:xfrm>
+      </p:grpSpPr>
+      <p:sp>
+        <p:nvSpPr>
+          <p:cNvPr id="2" name="Slide Image Placeholder 1"/>
+          <p:cNvSpPr>
+            <a:spLocks noGrp="1"/>
+          </p:cNvSpPr>
+          <p:nvPr>
+            <p:ph type="sldImg" idx="2"/>
+          </p:nvPr>
+        </p:nvSpPr>
+        <p:spPr/>
+      </p:sp>
+      <p:sp>
+        <p:nvSpPr>
+          <p:cNvPr id="3" name="Notes Placeholder 2"/>
+          <p:cNvSpPr>
+            <a:spLocks noGrp="1"/>
+          </p:cNvSpPr>
+          <p:nvPr>
+            <p:ph type="body" idx="3" sz="quarter"/>
+          </p:nvPr>
+        </p:nvSpPr>
+        <p:spPr/>
+        <p:txBody>
+          <a:bodyPr/>
+          <a:lstStyle/>
+          <a:p>
+            <a:r>
+              <a:t>[~45s] We didn't stop at shape. We also examined a completely different property — the molecules' electronic structure — as an independent check, and got the same story. The descriptor that looks strongest here, polarizability, turns out to be another stand-in for size and potency: it vanishes on the potency-free shift. But one quantity — a quantum-computed measure of water-versus-oil preference — independently points the same way as our surface lead. Two unrelated families of measurement converging on the same modest conclusion. When independent methods agree you trust the direction, even while being honest that the effect is small.</a:t>
+            </a:r>
+          </a:p>
+        </p:txBody>
+      </p:sp>
+      <p:sp>
+        <p:nvSpPr>
+          <p:cNvPr id="4" name="Slide Number Placeholder 3"/>
+          <p:cNvSpPr>
+            <a:spLocks noGrp="1"/>
+          </p:cNvSpPr>
+          <p:nvPr>
+            <p:ph type="sldNum" idx="5" sz="quarter"/>
+          </p:nvPr>
+        </p:nvSpPr>
+        <p:spPr/>
+      </p:sp>
+    </p:spTree>
+  </p:cSld>
+  <p:clrMapOvr>
+    <a:masterClrMapping/>
+  </p:clrMapOvr>
+</p:notes>
 </file>
 
 <file path=ppt/slideLayouts/slideLayout1.xml><?xml version="1.0" encoding="utf-8"?>
@@ -13246,4 +14856,324 @@
   </a:objectDefaults>
   <a:extraClrSchemeLst/>
 </a:theme>
+</file>
+
+<file path=ppt/theme/theme2.xml><?xml version="1.0" encoding="utf-8"?>
+<a:theme xmlns:a="http://schemas.openxmlformats.org/drawingml/2006/main" name="Office Theme">
+  <a:themeElements>
+    <a:clrScheme name="Office">
+      <a:dk1>
+        <a:sysClr val="windowText" lastClr="000000"/>
+      </a:dk1>
+      <a:lt1>
+        <a:sysClr val="window" lastClr="FFFFFF"/>
+      </a:lt1>
+      <a:dk2>
+        <a:srgbClr val="1F497D"/>
+      </a:dk2>
+      <a:lt2>
+        <a:srgbClr val="EEECE1"/>
+      </a:lt2>
+      <a:accent1>
+        <a:srgbClr val="4F81BD"/>
+      </a:accent1>
+      <a:accent2>
+        <a:srgbClr val="C0504D"/>
+      </a:accent2>
+      <a:accent3>
+        <a:srgbClr val="9BBB59"/>
+      </a:accent3>
+      <a:accent4>
+        <a:srgbClr val="8064A2"/>
+      </a:accent4>
+      <a:accent5>
+        <a:srgbClr val="4BACC6"/>
+      </a:accent5>
+      <a:accent6>
+        <a:srgbClr val="F79646"/>
+      </a:accent6>
+      <a:hlink>
+        <a:srgbClr val="0000FF"/>
+      </a:hlink>
+      <a:folHlink>
+        <a:srgbClr val="800080"/>
+      </a:folHlink>
+    </a:clrScheme>
+    <a:fontScheme name="Office">
+      <a:majorFont>
+        <a:latin typeface="Calibri"/>
+        <a:ea typeface=""/>
+        <a:cs typeface=""/>
+        <a:font script="Jpan" typeface="ＭＳ Ｐゴシック"/>
+        <a:font script="Hang" typeface="맑은 고딕"/>
+        <a:font script="Hans" typeface="宋体"/>
+        <a:font script="Hant" typeface="新細明體"/>
+        <a:font script="Arab" typeface="Times New Roman"/>
+        <a:font script="Hebr" typeface="Times New Roman"/>
+        <a:font script="Thai" typeface="Angsana New"/>
+        <a:font script="Ethi" typeface="Nyala"/>
+        <a:font script="Beng" typeface="Vrinda"/>
+        <a:font script="Gujr" typeface="Shruti"/>
+        <a:font script="Khmr" typeface="MoolBoran"/>
+        <a:font script="Knda" typeface="Tunga"/>
+        <a:font script="Guru" typeface="Raavi"/>
+        <a:font script="Cans" typeface="Euphemia"/>
+        <a:font script="Cher" typeface="Plantagenet Cherokee"/>
+        <a:font script="Yiii" typeface="Microsoft Yi Baiti"/>
+        <a:font script="Tibt" typeface="Microsoft Himalaya"/>
+        <a:font script="Thaa" typeface="MV Boli"/>
+        <a:font script="Deva" typeface="Mangal"/>
+        <a:font script="Telu" typeface="Gautami"/>
+        <a:font script="Taml" typeface="Latha"/>
+        <a:font script="Syrc" typeface="Estrangelo Edessa"/>
+        <a:font script="Orya" typeface="Kalinga"/>
+        <a:font script="Mlym" typeface="Kartika"/>
+        <a:font script="Laoo" typeface="DokChampa"/>
+        <a:font script="Sinh" typeface="Iskoola Pota"/>
+        <a:font script="Mong" typeface="Mongolian Baiti"/>
+        <a:font script="Viet" typeface="Times New Roman"/>
+        <a:font script="Uigh" typeface="Microsoft Uighur"/>
+        <a:font script="Geor" typeface="Sylfaen"/>
+      </a:majorFont>
+      <a:minorFont>
+        <a:latin typeface="Calibri"/>
+        <a:ea typeface=""/>
+        <a:cs typeface=""/>
+        <a:font script="Jpan" typeface="ＭＳ Ｐゴシック"/>
+        <a:font script="Hang" typeface="맑은 고딕"/>
+        <a:font script="Hans" typeface="宋体"/>
+        <a:font script="Hant" typeface="新細明體"/>
+        <a:font script="Arab" typeface="Arial"/>
+        <a:font script="Hebr" typeface="Arial"/>
+        <a:font script="Thai" typeface="Cordia New"/>
+        <a:font script="Ethi" typeface="Nyala"/>
+        <a:font script="Beng" typeface="Vrinda"/>
+        <a:font script="Gujr" typeface="Shruti"/>
+        <a:font script="Khmr" typeface="DaunPenh"/>
+        <a:font script="Knda" typeface="Tunga"/>
+        <a:font script="Guru" typeface="Raavi"/>
+        <a:font script="Cans" typeface="Euphemia"/>
+        <a:font script="Cher" typeface="Plantagenet Cherokee"/>
+        <a:font script="Yiii" typeface="Microsoft Yi Baiti"/>
+        <a:font script="Tibt" typeface="Microsoft Himalaya"/>
+        <a:font script="Thaa" typeface="MV Boli"/>
+        <a:font script="Deva" typeface="Mangal"/>
+        <a:font script="Telu" typeface="Gautami"/>
+        <a:font script="Taml" typeface="Latha"/>
+        <a:font script="Syrc" typeface="Estrangelo Edessa"/>
+        <a:font script="Orya" typeface="Kalinga"/>
+        <a:font script="Mlym" typeface="Kartika"/>
+        <a:font script="Laoo" typeface="DokChampa"/>
+        <a:font script="Sinh" typeface="Iskoola Pota"/>
+        <a:font script="Mong" typeface="Mongolian Baiti"/>
+        <a:font script="Viet" typeface="Arial"/>
+        <a:font script="Uigh" typeface="Microsoft Uighur"/>
+        <a:font script="Geor" typeface="Sylfaen"/>
+      </a:minorFont>
+    </a:fontScheme>
+    <a:fmtScheme name="Office">
+      <a:fillStyleLst>
+        <a:solidFill>
+          <a:schemeClr val="phClr"/>
+        </a:solidFill>
+        <a:gradFill rotWithShape="1">
+          <a:gsLst>
+            <a:gs pos="0">
+              <a:schemeClr val="phClr">
+                <a:tint val="50000"/>
+                <a:satMod val="300000"/>
+              </a:schemeClr>
+            </a:gs>
+            <a:gs pos="35000">
+              <a:schemeClr val="phClr">
+                <a:tint val="37000"/>
+                <a:satMod val="300000"/>
+              </a:schemeClr>
+            </a:gs>
+            <a:gs pos="100000">
+              <a:schemeClr val="phClr">
+                <a:tint val="15000"/>
+                <a:satMod val="350000"/>
+              </a:schemeClr>
+            </a:gs>
+          </a:gsLst>
+          <a:lin ang="16200000" scaled="1"/>
+        </a:gradFill>
+        <a:gradFill rotWithShape="1">
+          <a:gsLst>
+            <a:gs pos="0">
+              <a:schemeClr val="phClr">
+                <a:tint val="100000"/>
+                <a:shade val="100000"/>
+                <a:satMod val="130000"/>
+              </a:schemeClr>
+            </a:gs>
+            <a:gs pos="100000">
+              <a:schemeClr val="phClr">
+                <a:tint val="50000"/>
+                <a:shade val="100000"/>
+                <a:satMod val="350000"/>
+              </a:schemeClr>
+            </a:gs>
+          </a:gsLst>
+          <a:lin ang="16200000" scaled="0"/>
+        </a:gradFill>
+      </a:fillStyleLst>
+      <a:lnStyleLst>
+        <a:ln w="9525" cap="flat" cmpd="sng" algn="ctr">
+          <a:solidFill>
+            <a:schemeClr val="phClr">
+              <a:shade val="95000"/>
+              <a:satMod val="105000"/>
+            </a:schemeClr>
+          </a:solidFill>
+          <a:prstDash val="solid"/>
+        </a:ln>
+        <a:ln w="25400" cap="flat" cmpd="sng" algn="ctr">
+          <a:solidFill>
+            <a:schemeClr val="phClr"/>
+          </a:solidFill>
+          <a:prstDash val="solid"/>
+        </a:ln>
+        <a:ln w="38100" cap="flat" cmpd="sng" algn="ctr">
+          <a:solidFill>
+            <a:schemeClr val="phClr"/>
+          </a:solidFill>
+          <a:prstDash val="solid"/>
+        </a:ln>
+      </a:lnStyleLst>
+      <a:effectStyleLst>
+        <a:effectStyle>
+          <a:effectLst>
+            <a:outerShdw blurRad="40000" dist="20000" dir="5400000" rotWithShape="0">
+              <a:srgbClr val="000000">
+                <a:alpha val="38000"/>
+              </a:srgbClr>
+            </a:outerShdw>
+          </a:effectLst>
+        </a:effectStyle>
+        <a:effectStyle>
+          <a:effectLst>
+            <a:outerShdw blurRad="40000" dist="23000" dir="5400000" rotWithShape="0">
+              <a:srgbClr val="000000">
+                <a:alpha val="35000"/>
+              </a:srgbClr>
+            </a:outerShdw>
+          </a:effectLst>
+        </a:effectStyle>
+        <a:effectStyle>
+          <a:effectLst>
+            <a:outerShdw blurRad="40000" dist="23000" dir="5400000" rotWithShape="0">
+              <a:srgbClr val="000000">
+                <a:alpha val="35000"/>
+              </a:srgbClr>
+            </a:outerShdw>
+          </a:effectLst>
+          <a:scene3d>
+            <a:camera prst="orthographicFront">
+              <a:rot lat="0" lon="0" rev="0"/>
+            </a:camera>
+            <a:lightRig rig="threePt" dir="t">
+              <a:rot lat="0" lon="0" rev="1200000"/>
+            </a:lightRig>
+          </a:scene3d>
+          <a:sp3d>
+            <a:bevelT w="63500" h="25400"/>
+          </a:sp3d>
+        </a:effectStyle>
+      </a:effectStyleLst>
+      <a:bgFillStyleLst>
+        <a:solidFill>
+          <a:schemeClr val="phClr"/>
+        </a:solidFill>
+        <a:gradFill rotWithShape="1">
+          <a:gsLst>
+            <a:gs pos="0">
+              <a:schemeClr val="phClr">
+                <a:tint val="40000"/>
+                <a:satMod val="350000"/>
+              </a:schemeClr>
+            </a:gs>
+            <a:gs pos="40000">
+              <a:schemeClr val="phClr">
+                <a:tint val="45000"/>
+                <a:shade val="99000"/>
+                <a:satMod val="350000"/>
+              </a:schemeClr>
+            </a:gs>
+            <a:gs pos="100000">
+              <a:schemeClr val="phClr">
+                <a:shade val="20000"/>
+                <a:satMod val="255000"/>
+              </a:schemeClr>
+            </a:gs>
+          </a:gsLst>
+          <a:path path="circle">
+            <a:fillToRect l="50000" t="-80000" r="50000" b="180000"/>
+          </a:path>
+        </a:gradFill>
+        <a:gradFill rotWithShape="1">
+          <a:gsLst>
+            <a:gs pos="0">
+              <a:schemeClr val="phClr">
+                <a:tint val="80000"/>
+                <a:satMod val="300000"/>
+              </a:schemeClr>
+            </a:gs>
+            <a:gs pos="100000">
+              <a:schemeClr val="phClr">
+                <a:shade val="30000"/>
+                <a:satMod val="200000"/>
+              </a:schemeClr>
+            </a:gs>
+          </a:gsLst>
+          <a:path path="circle">
+            <a:fillToRect l="50000" t="50000" r="50000" b="50000"/>
+          </a:path>
+        </a:gradFill>
+      </a:bgFillStyleLst>
+    </a:fmtScheme>
+  </a:themeElements>
+  <a:objectDefaults>
+    <a:spDef>
+      <a:spPr/>
+      <a:bodyPr/>
+      <a:lstStyle/>
+      <a:style>
+        <a:lnRef idx="1">
+          <a:schemeClr val="accent1"/>
+        </a:lnRef>
+        <a:fillRef idx="3">
+          <a:schemeClr val="accent1"/>
+        </a:fillRef>
+        <a:effectRef idx="2">
+          <a:schemeClr val="accent1"/>
+        </a:effectRef>
+        <a:fontRef idx="minor">
+          <a:schemeClr val="lt1"/>
+        </a:fontRef>
+      </a:style>
+    </a:spDef>
+    <a:lnDef>
+      <a:spPr/>
+      <a:bodyPr/>
+      <a:lstStyle/>
+      <a:style>
+        <a:lnRef idx="2">
+          <a:schemeClr val="accent1"/>
+        </a:lnRef>
+        <a:fillRef idx="0">
+          <a:schemeClr val="accent1"/>
+        </a:fillRef>
+        <a:effectRef idx="1">
+          <a:schemeClr val="accent1"/>
+        </a:effectRef>
+        <a:fontRef idx="minor">
+          <a:schemeClr val="tx1"/>
+        </a:fontRef>
+      </a:style>
+    </a:lnDef>
+  </a:objectDefaults>
+  <a:extraClrSchemeLst/>
+</a:theme>
 </file>
</xml_diff>